<commit_message>
Add entity types, triggers, automation management, issue types and settings slides
Five more mechanics slides, the deck rebuilt and every slide image re-exported.

Co-Authored-By: Claude Opus 5.5 <noreply@anthropic.com>
</commit_message>
<xml_diff>
--- a/docs/harness-diagram.pptx
+++ b/docs/harness-diagram.pptx
@@ -15,9 +15,14 @@
     <p:sldId id="263" r:id="rId9"/>
     <p:sldId id="264" r:id="rId10"/>
     <p:sldId id="265" r:id="rId11"/>
+    <p:sldId id="266" r:id="rId12"/>
+    <p:sldId id="267" r:id="rId13"/>
+    <p:sldId id="268" r:id="rId14"/>
+    <p:sldId id="269" r:id="rId15"/>
+    <p:sldId id="270" r:id="rId16"/>
   </p:sldIdLst>
   <p:notesMasterIdLst>
-    <p:notesMasterId r:id="rId12"/>
+    <p:notesMasterId r:id="rId17"/>
   </p:notesMasterIdLst>
   <p:sldSz cx="12192000" cy="6858000"/>
   <p:notesSz cx="6858000" cy="12192000"/>
@@ -599,7 +604,7 @@
           <a:p>
             <a:r>
               <a:rPr lang="en-US" dirty="0"/>
-              <a:t>User actions. Swipe right approves: one commit, verified; an implementable entity with nothing implementing it starts an implementation run. Swipe left sends back with a comment: a chat run works on the entity. Chat, run on demand, stop a run, manage projects, edit entities and change settings.</a:t>
+              <a:t>Summarization. When a run stops, its Stop hook hands the artifacts it added, changed or deleted to the summarization sub-agent, which writes one summary entity per piece of work. Artifacts changed by the user's own commits make the entities over them artifact_ahead, and a summarization run rewrites their cards.</a:t>
             </a:r>
             <a:endParaRPr lang="en-US" dirty="0"/>
           </a:p>
@@ -623,6 +628,446 @@
             <a:fld id="{F7021451-1387-4CA6-816F-3879F97B5CBC}" type="slidenum">
               <a:rPr lang="en-US"/>
               <a:t>10</a:t>
+            </a:fld>
+            <a:endParaRPr lang="en-US"/>
+          </a:p>
+        </p:txBody>
+      </p:sp>
+    </p:spTree>
+    <p:extLst>
+      <p:ext uri="{BB962C8B-B14F-4D97-AF65-F5344CB8AC3E}">
+        <p14:creationId xmlns:p14="http://schemas.microsoft.com/office/powerpoint/2010/main" val="1024086991"/>
+      </p:ext>
+    </p:extLst>
+  </p:cSld>
+  <p:clrMapOvr>
+    <a:masterClrMapping/>
+  </p:clrMapOvr>
+</p:notes>
+</file>
+
+<file path=ppt/notesSlides/notesSlide11.xml><?xml version="1.0" encoding="utf-8"?>
+<p:notes xmlns:a="http://schemas.openxmlformats.org/drawingml/2006/main" xmlns:r="http://schemas.openxmlformats.org/officeDocument/2006/relationships" xmlns:p="http://schemas.openxmlformats.org/presentationml/2006/main">
+  <p:cSld>
+    <p:spTree>
+      <p:nvGrpSpPr>
+        <p:cNvPr id="1" name=""/>
+        <p:cNvGrpSpPr/>
+        <p:nvPr/>
+      </p:nvGrpSpPr>
+      <p:grpSpPr>
+        <a:xfrm>
+          <a:off x="0" y="0"/>
+          <a:ext cx="0" cy="0"/>
+          <a:chOff x="0" y="0"/>
+          <a:chExt cx="0" cy="0"/>
+        </a:xfrm>
+      </p:grpSpPr>
+      <p:sp>
+        <p:nvSpPr>
+          <p:cNvPr id="2" name="Slide Image Placeholder 1"/>
+          <p:cNvSpPr>
+            <a:spLocks noGrp="1" noRot="1" noChangeAspect="1"/>
+          </p:cNvSpPr>
+          <p:nvPr>
+            <p:ph type="sldImg"/>
+          </p:nvPr>
+        </p:nvSpPr>
+        <p:spPr/>
+      </p:sp>
+      <p:sp>
+        <p:nvSpPr>
+          <p:cNvPr id="3" name="Notes Placeholder 2"/>
+          <p:cNvSpPr>
+            <a:spLocks noGrp="1"/>
+          </p:cNvSpPr>
+          <p:nvPr>
+            <p:ph type="body" idx="1"/>
+          </p:nvPr>
+        </p:nvSpPr>
+        <p:spPr/>
+        <p:txBody>
+          <a:bodyPr/>
+          <a:lstStyle/>
+          <a:p>
+            <a:r>
+              <a:rPr lang="en-US" dirty="0"/>
+              <a:t>Consistency gate. Every write is checked while the run works. When it ends, the transaction passes the gate: card limit, type and references. Everything lands as one commit; what fails carries an issue entity. The consistency check reads the knowledge graph only, never the artifacts, and counts contradictions on each entity.</a:t>
+            </a:r>
+            <a:endParaRPr lang="en-US" dirty="0"/>
+          </a:p>
+        </p:txBody>
+      </p:sp>
+      <p:sp>
+        <p:nvSpPr>
+          <p:cNvPr id="4" name="Slide Number Placeholder 3"/>
+          <p:cNvSpPr>
+            <a:spLocks noGrp="1"/>
+          </p:cNvSpPr>
+          <p:nvPr>
+            <p:ph type="sldNum" sz="quarter" idx="10"/>
+          </p:nvPr>
+        </p:nvSpPr>
+        <p:spPr/>
+        <p:txBody>
+          <a:bodyPr/>
+          <a:lstStyle/>
+          <a:p>
+            <a:fld id="{F7021451-1387-4CA6-816F-3879F97B5CBC}" type="slidenum">
+              <a:rPr lang="en-US"/>
+              <a:t>11</a:t>
+            </a:fld>
+            <a:endParaRPr lang="en-US"/>
+          </a:p>
+        </p:txBody>
+      </p:sp>
+    </p:spTree>
+    <p:extLst>
+      <p:ext uri="{BB962C8B-B14F-4D97-AF65-F5344CB8AC3E}">
+        <p14:creationId xmlns:p14="http://schemas.microsoft.com/office/powerpoint/2010/main" val="1024086991"/>
+      </p:ext>
+    </p:extLst>
+  </p:cSld>
+  <p:clrMapOvr>
+    <a:masterClrMapping/>
+  </p:clrMapOvr>
+</p:notes>
+</file>
+
+<file path=ppt/notesSlides/notesSlide12.xml><?xml version="1.0" encoding="utf-8"?>
+<p:notes xmlns:a="http://schemas.openxmlformats.org/drawingml/2006/main" xmlns:r="http://schemas.openxmlformats.org/officeDocument/2006/relationships" xmlns:p="http://schemas.openxmlformats.org/presentationml/2006/main">
+  <p:cSld>
+    <p:spTree>
+      <p:nvGrpSpPr>
+        <p:cNvPr id="1" name=""/>
+        <p:cNvGrpSpPr/>
+        <p:nvPr/>
+      </p:nvGrpSpPr>
+      <p:grpSpPr>
+        <a:xfrm>
+          <a:off x="0" y="0"/>
+          <a:ext cx="0" cy="0"/>
+          <a:chOff x="0" y="0"/>
+          <a:chExt cx="0" cy="0"/>
+        </a:xfrm>
+      </p:grpSpPr>
+      <p:sp>
+        <p:nvSpPr>
+          <p:cNvPr id="2" name="Slide Image Placeholder 1"/>
+          <p:cNvSpPr>
+            <a:spLocks noGrp="1" noRot="1" noChangeAspect="1"/>
+          </p:cNvSpPr>
+          <p:nvPr>
+            <p:ph type="sldImg"/>
+          </p:nvPr>
+        </p:nvSpPr>
+        <p:spPr/>
+      </p:sp>
+      <p:sp>
+        <p:nvSpPr>
+          <p:cNvPr id="3" name="Notes Placeholder 2"/>
+          <p:cNvSpPr>
+            <a:spLocks noGrp="1"/>
+          </p:cNvSpPr>
+          <p:nvPr>
+            <p:ph type="body" idx="1"/>
+          </p:nvPr>
+        </p:nvSpPr>
+        <p:spPr/>
+        <p:txBody>
+          <a:bodyPr/>
+          <a:lstStyle/>
+          <a:p>
+            <a:r>
+              <a:rPr lang="en-US" dirty="0"/>
+              <a:t>Issue types. The kinds of issue the consistency check raises over the knowledge graph. By rule: unresolved references, cards over the character limit, types outside entity-types.tsv or their directory. By reading: contradiction, repetition, ambiguity, design gap, logical, naming, struct, verbose and split. Each finding is its own issue entity, concerning the entity at fault first and the entities it clashes with, repeats or belongs with, with two to four options to resolve it; the check fixes nothing itself.</a:t>
+            </a:r>
+            <a:endParaRPr lang="en-US" dirty="0"/>
+          </a:p>
+        </p:txBody>
+      </p:sp>
+      <p:sp>
+        <p:nvSpPr>
+          <p:cNvPr id="4" name="Slide Number Placeholder 3"/>
+          <p:cNvSpPr>
+            <a:spLocks noGrp="1"/>
+          </p:cNvSpPr>
+          <p:nvPr>
+            <p:ph type="sldNum" sz="quarter" idx="10"/>
+          </p:nvPr>
+        </p:nvSpPr>
+        <p:spPr/>
+        <p:txBody>
+          <a:bodyPr/>
+          <a:lstStyle/>
+          <a:p>
+            <a:fld id="{F7021451-1387-4CA6-816F-3879F97B5CBC}" type="slidenum">
+              <a:rPr lang="en-US"/>
+              <a:t>12</a:t>
+            </a:fld>
+            <a:endParaRPr lang="en-US"/>
+          </a:p>
+        </p:txBody>
+      </p:sp>
+    </p:spTree>
+    <p:extLst>
+      <p:ext uri="{BB962C8B-B14F-4D97-AF65-F5344CB8AC3E}">
+        <p14:creationId xmlns:p14="http://schemas.microsoft.com/office/powerpoint/2010/main" val="1024086991"/>
+      </p:ext>
+    </p:extLst>
+  </p:cSld>
+  <p:clrMapOvr>
+    <a:masterClrMapping/>
+  </p:clrMapOvr>
+</p:notes>
+</file>
+
+<file path=ppt/notesSlides/notesSlide13.xml><?xml version="1.0" encoding="utf-8"?>
+<p:notes xmlns:a="http://schemas.openxmlformats.org/drawingml/2006/main" xmlns:r="http://schemas.openxmlformats.org/officeDocument/2006/relationships" xmlns:p="http://schemas.openxmlformats.org/presentationml/2006/main">
+  <p:cSld>
+    <p:spTree>
+      <p:nvGrpSpPr>
+        <p:cNvPr id="1" name=""/>
+        <p:cNvGrpSpPr/>
+        <p:nvPr/>
+      </p:nvGrpSpPr>
+      <p:grpSpPr>
+        <a:xfrm>
+          <a:off x="0" y="0"/>
+          <a:ext cx="0" cy="0"/>
+          <a:chOff x="0" y="0"/>
+          <a:chExt cx="0" cy="0"/>
+        </a:xfrm>
+      </p:grpSpPr>
+      <p:sp>
+        <p:nvSpPr>
+          <p:cNvPr id="2" name="Slide Image Placeholder 1"/>
+          <p:cNvSpPr>
+            <a:spLocks noGrp="1" noRot="1" noChangeAspect="1"/>
+          </p:cNvSpPr>
+          <p:nvPr>
+            <p:ph type="sldImg"/>
+          </p:nvPr>
+        </p:nvSpPr>
+        <p:spPr/>
+      </p:sp>
+      <p:sp>
+        <p:nvSpPr>
+          <p:cNvPr id="3" name="Notes Placeholder 2"/>
+          <p:cNvSpPr>
+            <a:spLocks noGrp="1"/>
+          </p:cNvSpPr>
+          <p:nvPr>
+            <p:ph type="body" idx="1"/>
+          </p:nvPr>
+        </p:nvSpPr>
+        <p:spPr/>
+        <p:txBody>
+          <a:bodyPr/>
+          <a:lstStyle/>
+          <a:p>
+            <a:r>
+              <a:rPr lang="en-US" dirty="0"/>
+              <a:t>Git. One branch per workspace. A run lands as one commit: fast-forwarded when the main line has not moved, replayed onto the new tip otherwise, with a conflict entity over what changed meanwhile. Approval is one more commit. Automation runs queue one at a time; the user's chats run alongside.</a:t>
+            </a:r>
+            <a:endParaRPr lang="en-US" dirty="0"/>
+          </a:p>
+        </p:txBody>
+      </p:sp>
+      <p:sp>
+        <p:nvSpPr>
+          <p:cNvPr id="4" name="Slide Number Placeholder 3"/>
+          <p:cNvSpPr>
+            <a:spLocks noGrp="1"/>
+          </p:cNvSpPr>
+          <p:nvPr>
+            <p:ph type="sldNum" sz="quarter" idx="10"/>
+          </p:nvPr>
+        </p:nvSpPr>
+        <p:spPr/>
+        <p:txBody>
+          <a:bodyPr/>
+          <a:lstStyle/>
+          <a:p>
+            <a:fld id="{F7021451-1387-4CA6-816F-3879F97B5CBC}" type="slidenum">
+              <a:rPr lang="en-US"/>
+              <a:t>13</a:t>
+            </a:fld>
+            <a:endParaRPr lang="en-US"/>
+          </a:p>
+        </p:txBody>
+      </p:sp>
+    </p:spTree>
+    <p:extLst>
+      <p:ext uri="{BB962C8B-B14F-4D97-AF65-F5344CB8AC3E}">
+        <p14:creationId xmlns:p14="http://schemas.microsoft.com/office/powerpoint/2010/main" val="1024086991"/>
+      </p:ext>
+    </p:extLst>
+  </p:cSld>
+  <p:clrMapOvr>
+    <a:masterClrMapping/>
+  </p:clrMapOvr>
+</p:notes>
+</file>
+
+<file path=ppt/notesSlides/notesSlide14.xml><?xml version="1.0" encoding="utf-8"?>
+<p:notes xmlns:a="http://schemas.openxmlformats.org/drawingml/2006/main" xmlns:r="http://schemas.openxmlformats.org/officeDocument/2006/relationships" xmlns:p="http://schemas.openxmlformats.org/presentationml/2006/main">
+  <p:cSld>
+    <p:spTree>
+      <p:nvGrpSpPr>
+        <p:cNvPr id="1" name=""/>
+        <p:cNvGrpSpPr/>
+        <p:nvPr/>
+      </p:nvGrpSpPr>
+      <p:grpSpPr>
+        <a:xfrm>
+          <a:off x="0" y="0"/>
+          <a:ext cx="0" cy="0"/>
+          <a:chOff x="0" y="0"/>
+          <a:chExt cx="0" cy="0"/>
+        </a:xfrm>
+      </p:grpSpPr>
+      <p:sp>
+        <p:nvSpPr>
+          <p:cNvPr id="2" name="Slide Image Placeholder 1"/>
+          <p:cNvSpPr>
+            <a:spLocks noGrp="1" noRot="1" noChangeAspect="1"/>
+          </p:cNvSpPr>
+          <p:nvPr>
+            <p:ph type="sldImg"/>
+          </p:nvPr>
+        </p:nvSpPr>
+        <p:spPr/>
+      </p:sp>
+      <p:sp>
+        <p:nvSpPr>
+          <p:cNvPr id="3" name="Notes Placeholder 2"/>
+          <p:cNvSpPr>
+            <a:spLocks noGrp="1"/>
+          </p:cNvSpPr>
+          <p:nvPr>
+            <p:ph type="body" idx="1"/>
+          </p:nvPr>
+        </p:nvSpPr>
+        <p:spPr/>
+        <p:txBody>
+          <a:bodyPr/>
+          <a:lstStyle/>
+          <a:p>
+            <a:r>
+              <a:rPr lang="en-US" dirty="0"/>
+              <a:t>User actions. Swipe right approves: one commit, verified; an implementable entity with nothing implementing it starts an implementation run. Swipe left sends back with a comment: a chat run works on the entity. Chat, run on demand, stop a run, manage projects, edit entities and change settings.</a:t>
+            </a:r>
+            <a:endParaRPr lang="en-US" dirty="0"/>
+          </a:p>
+        </p:txBody>
+      </p:sp>
+      <p:sp>
+        <p:nvSpPr>
+          <p:cNvPr id="4" name="Slide Number Placeholder 3"/>
+          <p:cNvSpPr>
+            <a:spLocks noGrp="1"/>
+          </p:cNvSpPr>
+          <p:nvPr>
+            <p:ph type="sldNum" sz="quarter" idx="10"/>
+          </p:nvPr>
+        </p:nvSpPr>
+        <p:spPr/>
+        <p:txBody>
+          <a:bodyPr/>
+          <a:lstStyle/>
+          <a:p>
+            <a:fld id="{F7021451-1387-4CA6-816F-3879F97B5CBC}" type="slidenum">
+              <a:rPr lang="en-US"/>
+              <a:t>14</a:t>
+            </a:fld>
+            <a:endParaRPr lang="en-US"/>
+          </a:p>
+        </p:txBody>
+      </p:sp>
+    </p:spTree>
+    <p:extLst>
+      <p:ext uri="{BB962C8B-B14F-4D97-AF65-F5344CB8AC3E}">
+        <p14:creationId xmlns:p14="http://schemas.microsoft.com/office/powerpoint/2010/main" val="1024086991"/>
+      </p:ext>
+    </p:extLst>
+  </p:cSld>
+  <p:clrMapOvr>
+    <a:masterClrMapping/>
+  </p:clrMapOvr>
+</p:notes>
+</file>
+
+<file path=ppt/notesSlides/notesSlide15.xml><?xml version="1.0" encoding="utf-8"?>
+<p:notes xmlns:a="http://schemas.openxmlformats.org/drawingml/2006/main" xmlns:r="http://schemas.openxmlformats.org/officeDocument/2006/relationships" xmlns:p="http://schemas.openxmlformats.org/presentationml/2006/main">
+  <p:cSld>
+    <p:spTree>
+      <p:nvGrpSpPr>
+        <p:cNvPr id="1" name=""/>
+        <p:cNvGrpSpPr/>
+        <p:nvPr/>
+      </p:nvGrpSpPr>
+      <p:grpSpPr>
+        <a:xfrm>
+          <a:off x="0" y="0"/>
+          <a:ext cx="0" cy="0"/>
+          <a:chOff x="0" y="0"/>
+          <a:chExt cx="0" cy="0"/>
+        </a:xfrm>
+      </p:grpSpPr>
+      <p:sp>
+        <p:nvSpPr>
+          <p:cNvPr id="2" name="Slide Image Placeholder 1"/>
+          <p:cNvSpPr>
+            <a:spLocks noGrp="1" noRot="1" noChangeAspect="1"/>
+          </p:cNvSpPr>
+          <p:nvPr>
+            <p:ph type="sldImg"/>
+          </p:nvPr>
+        </p:nvSpPr>
+        <p:spPr/>
+      </p:sp>
+      <p:sp>
+        <p:nvSpPr>
+          <p:cNvPr id="3" name="Notes Placeholder 2"/>
+          <p:cNvSpPr>
+            <a:spLocks noGrp="1"/>
+          </p:cNvSpPr>
+          <p:nvPr>
+            <p:ph type="body" idx="1"/>
+          </p:nvPr>
+        </p:nvSpPr>
+        <p:spPr/>
+        <p:txBody>
+          <a:bodyPr/>
+          <a:lstStyle/>
+          <a:p>
+            <a:r>
+              <a:rPr lang="en-US" dirty="0"/>
+              <a:t>Settings. The Settings tab: theme on this device; included projects, each enabled or disabled, with its knowledge graph build; feed size, the items before loops pause; cards, the character limit and presentation rules; paths never summarized; lifetimes per entity type; concurrent runs in total; models, one for all, per automation or by implementation risk. Values shown are the harness defaults, with models shown by risk.</a:t>
+            </a:r>
+            <a:endParaRPr lang="en-US" dirty="0"/>
+          </a:p>
+        </p:txBody>
+      </p:sp>
+      <p:sp>
+        <p:nvSpPr>
+          <p:cNvPr id="4" name="Slide Number Placeholder 3"/>
+          <p:cNvSpPr>
+            <a:spLocks noGrp="1"/>
+          </p:cNvSpPr>
+          <p:nvPr>
+            <p:ph type="sldNum" sz="quarter" idx="10"/>
+          </p:nvPr>
+        </p:nvSpPr>
+        <p:spPr/>
+        <p:txBody>
+          <a:bodyPr/>
+          <a:lstStyle/>
+          <a:p>
+            <a:fld id="{F7021451-1387-4CA6-816F-3879F97B5CBC}" type="slidenum">
+              <a:rPr lang="en-US"/>
+              <a:t>15</a:t>
             </a:fld>
             <a:endParaRPr lang="en-US"/>
           </a:p>
@@ -775,7 +1220,7 @@
           <a:p>
             <a:r>
               <a:rPr lang="en-US" dirty="0"/>
-              <a:t>How everything works together. One loop per project. Triggers queue runs; each run works in its own checkout of the main line; summarization turns its artifacts into cards; the consistency gate validates the transaction and lands it as one commit; the index follows the main line and the feed ranks what is unverified; the user approves, sends back or chats. Runs the user starts go at once, alongside the queued automation runs.</a:t>
+              <a:t>How everything works together. One loop per project. Triggers queue runs; each run works in its own checkout of the main line; summarization turns its artifacts into cards; the consistency gate validates the transaction and lands it as one commit; the index follows the main line and the feed ranks what is unverified; the user approves, sends back or chats. A card the user writes needs no run: it goes straight through the consistency gate and lands verified. Runs the user starts go at once, alongside the queued automation runs.</a:t>
             </a:r>
             <a:endParaRPr lang="en-US" dirty="0"/>
           </a:p>
@@ -951,7 +1396,7 @@
           <a:p>
             <a:r>
               <a:rPr lang="en-US" dirty="0"/>
-              <a:t>Entity states. Verification is the user's judgement: approval verifies, any rewrite by a run makes the entity unverified again. Sync is the entity against its artifacts and implementation. Contradictions count the open contradiction issues over the entity.</a:t>
+              <a:t>Entity types. Every entity has one of the types in docs/entity-types.tsv, grouped in domains. The type is the path of the entity in the knowledge graph. The Harness domain holds the entities of Momentum itself: automations, triggers, issues, conflicts, chats, plans and research.</a:t>
             </a:r>
             <a:endParaRPr lang="en-US" dirty="0"/>
           </a:p>
@@ -1039,7 +1484,7 @@
           <a:p>
             <a:r>
               <a:rPr lang="en-US" dirty="0"/>
-              <a:t>Automations. Ten automations around the knowledge graph, each with its trigger: schedule, event, the user, the Stop hook or enabling the project. Automation runs go one at a time per project; runs the user starts go at once.</a:t>
+              <a:t>Entity states. Verification is the user's judgement: approval verifies, any rewrite by a run makes the entity unverified again. Sync is the entity against its artifacts and implementation. Contradictions count the open contradiction issues over the entity.</a:t>
             </a:r>
             <a:endParaRPr lang="en-US" dirty="0"/>
           </a:p>
@@ -1127,7 +1572,7 @@
           <a:p>
             <a:r>
               <a:rPr lang="en-US" dirty="0"/>
-              <a:t>Summarization. When a run stops, its Stop hook hands the artifacts it added, changed or deleted to the summarization sub-agent, which writes one summary entity per piece of work. Artifacts changed by the user's own commits make the entities over them artifact_ahead, and a summarization run rewrites their cards.</a:t>
+              <a:t>Automations. Ten automations around the knowledge graph, each with its trigger: schedule, event, the user, the Stop hook or enabling the project. Automation runs go one at a time per project; runs the user starts go at once.</a:t>
             </a:r>
             <a:endParaRPr lang="en-US" dirty="0"/>
           </a:p>
@@ -1215,7 +1660,7 @@
           <a:p>
             <a:r>
               <a:rPr lang="en-US" dirty="0"/>
-              <a:t>Consistency gate. Every write is checked while the run works. When it ends, the transaction passes the gate: card limit, type and references. Everything lands as one commit; what fails carries an issue entity. The consistency check reads the knowledge graph only, never the artifacts, and counts contradictions on each entity.</a:t>
+              <a:t>Triggers. Each automation has a trigger entity in each workspace, holding its schedule, its events and whether it starts on demand. Exploration every two hours, preparation every two hours at half past, validation at 02:00, consistency check at 03:00, retention at 04:00, optimization at 05:00. An approved entity with nothing implementing it starts implementation; a finished implementation starts validation. Summarization runs in the Stop hook of every run and graph build while the project is enabled, so neither has a trigger entity. Triggered loops pause while the feed is at its limit.</a:t>
             </a:r>
             <a:endParaRPr lang="en-US" dirty="0"/>
           </a:p>
@@ -1303,7 +1748,7 @@
           <a:p>
             <a:r>
               <a:rPr lang="en-US" dirty="0"/>
-              <a:t>Git. One branch per workspace. A run lands as one commit: fast-forwarded when the main line has not moved, replayed onto the new tip otherwise, with a conflict entity over what changed meanwhile. Approval is one more commit. Automation runs queue one at a time; the user's chats run alongside.</a:t>
+              <a:t>Automation management. Automations are configured through the knowledge base, not through settings. The definition is an entity in the harness workspace, one per automation, with the Claude Code files as its artifacts; the triggers are an entity per automation in each workspace. The user edits them, or optimization proposes changes; either way the change passes the consistency gate, lands on the main line and is verified through the feed. Runs start on demand from the chat and stop from the chat; models and concurrency are settings.</a:t>
             </a:r>
             <a:endParaRPr lang="en-US" dirty="0"/>
           </a:p>
@@ -4938,7 +5383,7 @@
         </p:blipFill>
         <p:spPr>
           <a:xfrm>
-            <a:off x="7024939" y="4238244"/>
+            <a:off x="7001002" y="4238244"/>
             <a:ext cx="155448" cy="155448"/>
           </a:xfrm>
           <a:prstGeom prst="rect">
@@ -4954,8 +5399,8 @@
         </p:nvSpPr>
         <p:spPr>
           <a:xfrm>
-            <a:off x="7244395" y="4160520"/>
-            <a:ext cx="406787" cy="310896"/>
+            <a:off x="7220458" y="4160520"/>
+            <a:ext cx="454660" cy="310896"/>
           </a:xfrm>
           <a:prstGeom prst="rect">
             <a:avLst/>
@@ -5033,7 +5478,7 @@
         </p:blipFill>
         <p:spPr>
           <a:xfrm>
-            <a:off x="7048596" y="4640580"/>
+            <a:off x="7032752" y="4640580"/>
             <a:ext cx="155448" cy="155448"/>
           </a:xfrm>
           <a:prstGeom prst="rect">
@@ -5049,8 +5494,8 @@
         </p:nvSpPr>
         <p:spPr>
           <a:xfrm>
-            <a:off x="7268052" y="4562856"/>
-            <a:ext cx="359472" cy="310896"/>
+            <a:off x="7252208" y="4562856"/>
+            <a:ext cx="391160" cy="310896"/>
           </a:xfrm>
           <a:prstGeom prst="rect">
             <a:avLst/>
@@ -5128,7 +5573,7 @@
         </p:blipFill>
         <p:spPr>
           <a:xfrm>
-            <a:off x="6967268" y="5042916"/>
+            <a:off x="6969252" y="5042916"/>
             <a:ext cx="155448" cy="155448"/>
           </a:xfrm>
           <a:prstGeom prst="rect">
@@ -5144,8 +5589,8 @@
         </p:nvSpPr>
         <p:spPr>
           <a:xfrm>
-            <a:off x="7186724" y="4965192"/>
-            <a:ext cx="522129" cy="310896"/>
+            <a:off x="7188708" y="4965192"/>
+            <a:ext cx="518160" cy="310896"/>
           </a:xfrm>
           <a:prstGeom prst="rect">
             <a:avLst/>
@@ -5223,7 +5668,7 @@
         </p:blipFill>
         <p:spPr>
           <a:xfrm>
-            <a:off x="7061960" y="5445252"/>
+            <a:off x="7064502" y="5445252"/>
             <a:ext cx="155448" cy="155448"/>
           </a:xfrm>
           <a:prstGeom prst="rect">
@@ -5239,8 +5684,8 @@
         </p:nvSpPr>
         <p:spPr>
           <a:xfrm>
-            <a:off x="7281416" y="5367528"/>
-            <a:ext cx="332745" cy="310896"/>
+            <a:off x="7283958" y="5367528"/>
+            <a:ext cx="327660" cy="310896"/>
           </a:xfrm>
           <a:prstGeom prst="rect">
             <a:avLst/>
@@ -5318,7 +5763,7 @@
         </p:blipFill>
         <p:spPr>
           <a:xfrm>
-            <a:off x="6940137" y="5847588"/>
+            <a:off x="6905752" y="5847588"/>
             <a:ext cx="155448" cy="155448"/>
           </a:xfrm>
           <a:prstGeom prst="rect">
@@ -5334,8 +5779,8 @@
         </p:nvSpPr>
         <p:spPr>
           <a:xfrm>
-            <a:off x="7159593" y="5769864"/>
-            <a:ext cx="576389" cy="310896"/>
+            <a:off x="7125208" y="5769864"/>
+            <a:ext cx="645160" cy="310896"/>
           </a:xfrm>
           <a:prstGeom prst="rect">
             <a:avLst/>
@@ -5979,7 +6424,492 @@
                 <a:ea typeface="Cambria" pitchFamily="34" charset="-122"/>
                 <a:cs typeface="Cambria" pitchFamily="34" charset="-120"/>
               </a:rPr>
+              <a:t>Summarization</a:t>
+            </a:r>
+            <a:endParaRPr lang="en-US" sz="2000" dirty="0"/>
+          </a:p>
+        </p:txBody>
+      </p:sp>
+      <p:pic>
+        <p:nvPicPr>
+          <p:cNvPr id="4" name="Image 0" descr="preencoded.png">    </p:cNvPr>
+          <p:cNvPicPr>
+            <a:picLocks noChangeAspect="1"/>
+          </p:cNvPicPr>
+          <p:nvPr/>
+        </p:nvPicPr>
+        <p:blipFill>
+          <a:blip r:embed="rId1"/>
+          <a:stretch>
+            <a:fillRect/>
+          </a:stretch>
+        </p:blipFill>
+        <p:spPr>
+          <a:xfrm>
+            <a:off x="0" y="822960"/>
+            <a:ext cx="12191695" cy="6032349"/>
+          </a:xfrm>
+          <a:prstGeom prst="rect">
+            <a:avLst/>
+          </a:prstGeom>
+        </p:spPr>
+      </p:pic>
+    </p:spTree>
+  </p:cSld>
+  <p:clrMapOvr>
+    <a:masterClrMapping/>
+  </p:clrMapOvr>
+</p:sld>
+</file>
+
+<file path=ppt/slides/slide11.xml><?xml version="1.0" encoding="utf-8"?>
+<p:sld xmlns:a="http://schemas.openxmlformats.org/drawingml/2006/main" xmlns:r="http://schemas.openxmlformats.org/officeDocument/2006/relationships" xmlns:p="http://schemas.openxmlformats.org/presentationml/2006/main">
+  <p:cSld name="Slide 11">
+    <p:bg>
+      <p:bgPr>
+        <a:solidFill>
+          <a:srgbClr val="FFFFFF"/>
+        </a:solidFill>
+      </p:bgPr>
+    </p:bg>
+    <p:spTree>
+      <p:nvGrpSpPr>
+        <p:cNvPr id="1" name=""/>
+        <p:cNvGrpSpPr/>
+        <p:nvPr/>
+      </p:nvGrpSpPr>
+      <p:grpSpPr>
+        <a:xfrm>
+          <a:off x="0" y="0"/>
+          <a:ext cx="0" cy="0"/>
+          <a:chOff x="0" y="0"/>
+          <a:chExt cx="0" cy="0"/>
+        </a:xfrm>
+      </p:grpSpPr>
+      <p:sp>
+        <p:nvSpPr>
+          <p:cNvPr id="3" name="Text 0"/>
+          <p:cNvSpPr txBox="1"/>
+          <p:nvPr/>
+        </p:nvSpPr>
+        <p:spPr>
+          <a:xfrm>
+            <a:off x="320040" y="274320"/>
+            <a:ext cx="4937760" cy="457200"/>
+          </a:xfrm>
+          <a:prstGeom prst="rect">
+            <a:avLst/>
+          </a:prstGeom>
+          <a:solidFill>
+            <a:srgbClr val="2F3E46"/>
+          </a:solidFill>
+          <a:ln/>
+        </p:spPr>
+        <p:txBody>
+          <a:bodyPr wrap="square" lIns="177800" tIns="63500" rIns="177800" bIns="0" rtlCol="0" anchor="ctr"/>
+          <a:lstStyle/>
+          <a:p>
+            <a:pPr algn="l" indent="0" marL="0">
+              <a:buNone/>
+            </a:pPr>
+            <a:r>
+              <a:rPr lang="en-US" sz="2000" dirty="0">
+                <a:solidFill>
+                  <a:srgbClr val="FFFFFF"/>
+                </a:solidFill>
+                <a:latin typeface="Cambria" pitchFamily="34" charset="0"/>
+                <a:ea typeface="Cambria" pitchFamily="34" charset="-122"/>
+                <a:cs typeface="Cambria" pitchFamily="34" charset="-120"/>
+              </a:rPr>
+              <a:t>Consistency gate</a:t>
+            </a:r>
+            <a:endParaRPr lang="en-US" sz="2000" dirty="0"/>
+          </a:p>
+        </p:txBody>
+      </p:sp>
+      <p:pic>
+        <p:nvPicPr>
+          <p:cNvPr id="4" name="Image 0" descr="preencoded.png">    </p:cNvPr>
+          <p:cNvPicPr>
+            <a:picLocks noChangeAspect="1"/>
+          </p:cNvPicPr>
+          <p:nvPr/>
+        </p:nvPicPr>
+        <p:blipFill>
+          <a:blip r:embed="rId1"/>
+          <a:stretch>
+            <a:fillRect/>
+          </a:stretch>
+        </p:blipFill>
+        <p:spPr>
+          <a:xfrm>
+            <a:off x="0" y="822960"/>
+            <a:ext cx="12191695" cy="6032349"/>
+          </a:xfrm>
+          <a:prstGeom prst="rect">
+            <a:avLst/>
+          </a:prstGeom>
+        </p:spPr>
+      </p:pic>
+    </p:spTree>
+  </p:cSld>
+  <p:clrMapOvr>
+    <a:masterClrMapping/>
+  </p:clrMapOvr>
+</p:sld>
+</file>
+
+<file path=ppt/slides/slide12.xml><?xml version="1.0" encoding="utf-8"?>
+<p:sld xmlns:a="http://schemas.openxmlformats.org/drawingml/2006/main" xmlns:r="http://schemas.openxmlformats.org/officeDocument/2006/relationships" xmlns:p="http://schemas.openxmlformats.org/presentationml/2006/main">
+  <p:cSld name="Slide 12">
+    <p:bg>
+      <p:bgPr>
+        <a:solidFill>
+          <a:srgbClr val="FFFFFF"/>
+        </a:solidFill>
+      </p:bgPr>
+    </p:bg>
+    <p:spTree>
+      <p:nvGrpSpPr>
+        <p:cNvPr id="1" name=""/>
+        <p:cNvGrpSpPr/>
+        <p:nvPr/>
+      </p:nvGrpSpPr>
+      <p:grpSpPr>
+        <a:xfrm>
+          <a:off x="0" y="0"/>
+          <a:ext cx="0" cy="0"/>
+          <a:chOff x="0" y="0"/>
+          <a:chExt cx="0" cy="0"/>
+        </a:xfrm>
+      </p:grpSpPr>
+      <p:sp>
+        <p:nvSpPr>
+          <p:cNvPr id="3" name="Text 0"/>
+          <p:cNvSpPr txBox="1"/>
+          <p:nvPr/>
+        </p:nvSpPr>
+        <p:spPr>
+          <a:xfrm>
+            <a:off x="320040" y="274320"/>
+            <a:ext cx="4937760" cy="457200"/>
+          </a:xfrm>
+          <a:prstGeom prst="rect">
+            <a:avLst/>
+          </a:prstGeom>
+          <a:solidFill>
+            <a:srgbClr val="2F3E46"/>
+          </a:solidFill>
+          <a:ln/>
+        </p:spPr>
+        <p:txBody>
+          <a:bodyPr wrap="square" lIns="177800" tIns="63500" rIns="177800" bIns="0" rtlCol="0" anchor="ctr"/>
+          <a:lstStyle/>
+          <a:p>
+            <a:pPr algn="l" indent="0" marL="0">
+              <a:buNone/>
+            </a:pPr>
+            <a:r>
+              <a:rPr lang="en-US" sz="2000" dirty="0">
+                <a:solidFill>
+                  <a:srgbClr val="FFFFFF"/>
+                </a:solidFill>
+                <a:latin typeface="Cambria" pitchFamily="34" charset="0"/>
+                <a:ea typeface="Cambria" pitchFamily="34" charset="-122"/>
+                <a:cs typeface="Cambria" pitchFamily="34" charset="-120"/>
+              </a:rPr>
+              <a:t>Issue types</a:t>
+            </a:r>
+            <a:endParaRPr lang="en-US" sz="2000" dirty="0"/>
+          </a:p>
+        </p:txBody>
+      </p:sp>
+      <p:pic>
+        <p:nvPicPr>
+          <p:cNvPr id="4" name="Image 0" descr="preencoded.png">    </p:cNvPr>
+          <p:cNvPicPr>
+            <a:picLocks noChangeAspect="1"/>
+          </p:cNvPicPr>
+          <p:nvPr/>
+        </p:nvPicPr>
+        <p:blipFill>
+          <a:blip r:embed="rId1"/>
+          <a:stretch>
+            <a:fillRect/>
+          </a:stretch>
+        </p:blipFill>
+        <p:spPr>
+          <a:xfrm>
+            <a:off x="0" y="822960"/>
+            <a:ext cx="12191695" cy="6032349"/>
+          </a:xfrm>
+          <a:prstGeom prst="rect">
+            <a:avLst/>
+          </a:prstGeom>
+        </p:spPr>
+      </p:pic>
+    </p:spTree>
+  </p:cSld>
+  <p:clrMapOvr>
+    <a:masterClrMapping/>
+  </p:clrMapOvr>
+</p:sld>
+</file>
+
+<file path=ppt/slides/slide13.xml><?xml version="1.0" encoding="utf-8"?>
+<p:sld xmlns:a="http://schemas.openxmlformats.org/drawingml/2006/main" xmlns:r="http://schemas.openxmlformats.org/officeDocument/2006/relationships" xmlns:p="http://schemas.openxmlformats.org/presentationml/2006/main">
+  <p:cSld name="Slide 13">
+    <p:bg>
+      <p:bgPr>
+        <a:solidFill>
+          <a:srgbClr val="FFFFFF"/>
+        </a:solidFill>
+      </p:bgPr>
+    </p:bg>
+    <p:spTree>
+      <p:nvGrpSpPr>
+        <p:cNvPr id="1" name=""/>
+        <p:cNvGrpSpPr/>
+        <p:nvPr/>
+      </p:nvGrpSpPr>
+      <p:grpSpPr>
+        <a:xfrm>
+          <a:off x="0" y="0"/>
+          <a:ext cx="0" cy="0"/>
+          <a:chOff x="0" y="0"/>
+          <a:chExt cx="0" cy="0"/>
+        </a:xfrm>
+      </p:grpSpPr>
+      <p:sp>
+        <p:nvSpPr>
+          <p:cNvPr id="3" name="Text 0"/>
+          <p:cNvSpPr txBox="1"/>
+          <p:nvPr/>
+        </p:nvSpPr>
+        <p:spPr>
+          <a:xfrm>
+            <a:off x="320040" y="274320"/>
+            <a:ext cx="4937760" cy="457200"/>
+          </a:xfrm>
+          <a:prstGeom prst="rect">
+            <a:avLst/>
+          </a:prstGeom>
+          <a:solidFill>
+            <a:srgbClr val="2F3E46"/>
+          </a:solidFill>
+          <a:ln/>
+        </p:spPr>
+        <p:txBody>
+          <a:bodyPr wrap="square" lIns="177800" tIns="63500" rIns="177800" bIns="0" rtlCol="0" anchor="ctr"/>
+          <a:lstStyle/>
+          <a:p>
+            <a:pPr algn="l" indent="0" marL="0">
+              <a:buNone/>
+            </a:pPr>
+            <a:r>
+              <a:rPr lang="en-US" sz="2000" dirty="0">
+                <a:solidFill>
+                  <a:srgbClr val="FFFFFF"/>
+                </a:solidFill>
+                <a:latin typeface="Cambria" pitchFamily="34" charset="0"/>
+                <a:ea typeface="Cambria" pitchFamily="34" charset="-122"/>
+                <a:cs typeface="Cambria" pitchFamily="34" charset="-120"/>
+              </a:rPr>
+              <a:t>Git</a:t>
+            </a:r>
+            <a:endParaRPr lang="en-US" sz="2000" dirty="0"/>
+          </a:p>
+        </p:txBody>
+      </p:sp>
+      <p:pic>
+        <p:nvPicPr>
+          <p:cNvPr id="4" name="Image 0" descr="preencoded.png">    </p:cNvPr>
+          <p:cNvPicPr>
+            <a:picLocks noChangeAspect="1"/>
+          </p:cNvPicPr>
+          <p:nvPr/>
+        </p:nvPicPr>
+        <p:blipFill>
+          <a:blip r:embed="rId1"/>
+          <a:stretch>
+            <a:fillRect/>
+          </a:stretch>
+        </p:blipFill>
+        <p:spPr>
+          <a:xfrm>
+            <a:off x="0" y="822960"/>
+            <a:ext cx="12191695" cy="6032349"/>
+          </a:xfrm>
+          <a:prstGeom prst="rect">
+            <a:avLst/>
+          </a:prstGeom>
+        </p:spPr>
+      </p:pic>
+    </p:spTree>
+  </p:cSld>
+  <p:clrMapOvr>
+    <a:masterClrMapping/>
+  </p:clrMapOvr>
+</p:sld>
+</file>
+
+<file path=ppt/slides/slide14.xml><?xml version="1.0" encoding="utf-8"?>
+<p:sld xmlns:a="http://schemas.openxmlformats.org/drawingml/2006/main" xmlns:r="http://schemas.openxmlformats.org/officeDocument/2006/relationships" xmlns:p="http://schemas.openxmlformats.org/presentationml/2006/main">
+  <p:cSld name="Slide 14">
+    <p:bg>
+      <p:bgPr>
+        <a:solidFill>
+          <a:srgbClr val="FFFFFF"/>
+        </a:solidFill>
+      </p:bgPr>
+    </p:bg>
+    <p:spTree>
+      <p:nvGrpSpPr>
+        <p:cNvPr id="1" name=""/>
+        <p:cNvGrpSpPr/>
+        <p:nvPr/>
+      </p:nvGrpSpPr>
+      <p:grpSpPr>
+        <a:xfrm>
+          <a:off x="0" y="0"/>
+          <a:ext cx="0" cy="0"/>
+          <a:chOff x="0" y="0"/>
+          <a:chExt cx="0" cy="0"/>
+        </a:xfrm>
+      </p:grpSpPr>
+      <p:sp>
+        <p:nvSpPr>
+          <p:cNvPr id="3" name="Text 0"/>
+          <p:cNvSpPr txBox="1"/>
+          <p:nvPr/>
+        </p:nvSpPr>
+        <p:spPr>
+          <a:xfrm>
+            <a:off x="320040" y="274320"/>
+            <a:ext cx="4937760" cy="457200"/>
+          </a:xfrm>
+          <a:prstGeom prst="rect">
+            <a:avLst/>
+          </a:prstGeom>
+          <a:solidFill>
+            <a:srgbClr val="2F3E46"/>
+          </a:solidFill>
+          <a:ln/>
+        </p:spPr>
+        <p:txBody>
+          <a:bodyPr wrap="square" lIns="177800" tIns="63500" rIns="177800" bIns="0" rtlCol="0" anchor="ctr"/>
+          <a:lstStyle/>
+          <a:p>
+            <a:pPr algn="l" indent="0" marL="0">
+              <a:buNone/>
+            </a:pPr>
+            <a:r>
+              <a:rPr lang="en-US" sz="2000" dirty="0">
+                <a:solidFill>
+                  <a:srgbClr val="FFFFFF"/>
+                </a:solidFill>
+                <a:latin typeface="Cambria" pitchFamily="34" charset="0"/>
+                <a:ea typeface="Cambria" pitchFamily="34" charset="-122"/>
+                <a:cs typeface="Cambria" pitchFamily="34" charset="-120"/>
+              </a:rPr>
               <a:t>User actions</a:t>
+            </a:r>
+            <a:endParaRPr lang="en-US" sz="2000" dirty="0"/>
+          </a:p>
+        </p:txBody>
+      </p:sp>
+      <p:pic>
+        <p:nvPicPr>
+          <p:cNvPr id="4" name="Image 0" descr="preencoded.png">    </p:cNvPr>
+          <p:cNvPicPr>
+            <a:picLocks noChangeAspect="1"/>
+          </p:cNvPicPr>
+          <p:nvPr/>
+        </p:nvPicPr>
+        <p:blipFill>
+          <a:blip r:embed="rId1"/>
+          <a:stretch>
+            <a:fillRect/>
+          </a:stretch>
+        </p:blipFill>
+        <p:spPr>
+          <a:xfrm>
+            <a:off x="0" y="822960"/>
+            <a:ext cx="12191695" cy="6032349"/>
+          </a:xfrm>
+          <a:prstGeom prst="rect">
+            <a:avLst/>
+          </a:prstGeom>
+        </p:spPr>
+      </p:pic>
+    </p:spTree>
+  </p:cSld>
+  <p:clrMapOvr>
+    <a:masterClrMapping/>
+  </p:clrMapOvr>
+</p:sld>
+</file>
+
+<file path=ppt/slides/slide15.xml><?xml version="1.0" encoding="utf-8"?>
+<p:sld xmlns:a="http://schemas.openxmlformats.org/drawingml/2006/main" xmlns:r="http://schemas.openxmlformats.org/officeDocument/2006/relationships" xmlns:p="http://schemas.openxmlformats.org/presentationml/2006/main">
+  <p:cSld name="Slide 15">
+    <p:bg>
+      <p:bgPr>
+        <a:solidFill>
+          <a:srgbClr val="FFFFFF"/>
+        </a:solidFill>
+      </p:bgPr>
+    </p:bg>
+    <p:spTree>
+      <p:nvGrpSpPr>
+        <p:cNvPr id="1" name=""/>
+        <p:cNvGrpSpPr/>
+        <p:nvPr/>
+      </p:nvGrpSpPr>
+      <p:grpSpPr>
+        <a:xfrm>
+          <a:off x="0" y="0"/>
+          <a:ext cx="0" cy="0"/>
+          <a:chOff x="0" y="0"/>
+          <a:chExt cx="0" cy="0"/>
+        </a:xfrm>
+      </p:grpSpPr>
+      <p:sp>
+        <p:nvSpPr>
+          <p:cNvPr id="3" name="Text 0"/>
+          <p:cNvSpPr txBox="1"/>
+          <p:nvPr/>
+        </p:nvSpPr>
+        <p:spPr>
+          <a:xfrm>
+            <a:off x="320040" y="274320"/>
+            <a:ext cx="4937760" cy="457200"/>
+          </a:xfrm>
+          <a:prstGeom prst="rect">
+            <a:avLst/>
+          </a:prstGeom>
+          <a:solidFill>
+            <a:srgbClr val="2F3E46"/>
+          </a:solidFill>
+          <a:ln/>
+        </p:spPr>
+        <p:txBody>
+          <a:bodyPr wrap="square" lIns="177800" tIns="63500" rIns="177800" bIns="0" rtlCol="0" anchor="ctr"/>
+          <a:lstStyle/>
+          <a:p>
+            <a:pPr algn="l" indent="0" marL="0">
+              <a:buNone/>
+            </a:pPr>
+            <a:r>
+              <a:rPr lang="en-US" sz="2000" dirty="0">
+                <a:solidFill>
+                  <a:srgbClr val="FFFFFF"/>
+                </a:solidFill>
+                <a:latin typeface="Cambria" pitchFamily="34" charset="0"/>
+                <a:ea typeface="Cambria" pitchFamily="34" charset="-122"/>
+                <a:cs typeface="Cambria" pitchFamily="34" charset="-120"/>
+              </a:rPr>
+              <a:t>Settings</a:t>
             </a:r>
             <a:endParaRPr lang="en-US" sz="2000" dirty="0"/>
           </a:p>
@@ -9805,7 +10735,7 @@
                 <a:ea typeface="Cambria" pitchFamily="34" charset="-122"/>
                 <a:cs typeface="Cambria" pitchFamily="34" charset="-120"/>
               </a:rPr>
-              <a:t>Entity states</a:t>
+              <a:t>Entity types</a:t>
             </a:r>
             <a:endParaRPr lang="en-US" sz="2000" dirty="0"/>
           </a:p>
@@ -9902,7 +10832,7 @@
                 <a:ea typeface="Cambria" pitchFamily="34" charset="-122"/>
                 <a:cs typeface="Cambria" pitchFamily="34" charset="-120"/>
               </a:rPr>
-              <a:t>Automations</a:t>
+              <a:t>Entity states</a:t>
             </a:r>
             <a:endParaRPr lang="en-US" sz="2000" dirty="0"/>
           </a:p>
@@ -9999,7 +10929,7 @@
                 <a:ea typeface="Cambria" pitchFamily="34" charset="-122"/>
                 <a:cs typeface="Cambria" pitchFamily="34" charset="-120"/>
               </a:rPr>
-              <a:t>Summarization</a:t>
+              <a:t>Automations</a:t>
             </a:r>
             <a:endParaRPr lang="en-US" sz="2000" dirty="0"/>
           </a:p>
@@ -10096,7 +11026,7 @@
                 <a:ea typeface="Cambria" pitchFamily="34" charset="-122"/>
                 <a:cs typeface="Cambria" pitchFamily="34" charset="-120"/>
               </a:rPr>
-              <a:t>Consistency gate</a:t>
+              <a:t>Triggers</a:t>
             </a:r>
             <a:endParaRPr lang="en-US" sz="2000" dirty="0"/>
           </a:p>
@@ -10193,7 +11123,7 @@
                 <a:ea typeface="Cambria" pitchFamily="34" charset="-122"/>
                 <a:cs typeface="Cambria" pitchFamily="34" charset="-120"/>
               </a:rPr>
-              <a:t>Git</a:t>
+              <a:t>Automation management</a:t>
             </a:r>
             <a:endParaRPr lang="en-US" sz="2000" dirty="0"/>
           </a:p>

</xml_diff>

<commit_message>
Introduce three severities for the content issue categories
High: contradiction, logical, ambiguity. Medium: design gap, naming, repetition. Low: verbose, struct, split. The consistency check sets `severity` on every content-category issue; the issue types slide groups its tiles in one row per severity. The deck is rebuilt and the slide re-exported.

Co-Authored-By: Claude Opus 5.5 <noreply@anthropic.com>
</commit_message>
<xml_diff>
--- a/docs/harness-diagram.pptx
+++ b/docs/harness-diagram.pptx
@@ -780,7 +780,7 @@
           <a:p>
             <a:r>
               <a:rPr lang="en-US" dirty="0"/>
-              <a:t>Issue types. The kinds of issue the consistency check raises over the knowledge graph. By rule: unresolved references, cards over the character limit, types outside entity-types.tsv or their directory. By reading: contradiction, repetition, ambiguity, design gap, logical, naming, struct, verbose and split. Each finding is its own issue entity, concerning the entity at fault first and the entities it clashes with, repeats or belongs with, with two to four options to resolve it; the check fixes nothing itself.</a:t>
+              <a:t>Issue types. The kinds of issue the consistency check raises over the knowledge graph. By rule: unresolved references, cards over the character limit, types outside entity-types.tsv or their directory. By reading, in three severities: high for contradiction, logical and ambiguity; medium for design gap, naming and repetition; low for verbose, struct and split. Each finding is its own issue entity, concerning the entity at fault first and the entities it clashes with, repeats or belongs with, with two to four options to resolve it; the check fixes nothing itself.</a:t>
             </a:r>
             <a:endParaRPr lang="en-US" dirty="0"/>
           </a:p>
@@ -5383,7 +5383,7 @@
         </p:blipFill>
         <p:spPr>
           <a:xfrm>
-            <a:off x="7001002" y="4238244"/>
+            <a:off x="7024939" y="4238244"/>
             <a:ext cx="155448" cy="155448"/>
           </a:xfrm>
           <a:prstGeom prst="rect">
@@ -5399,8 +5399,8 @@
         </p:nvSpPr>
         <p:spPr>
           <a:xfrm>
-            <a:off x="7220458" y="4160520"/>
-            <a:ext cx="454660" cy="310896"/>
+            <a:off x="7244395" y="4160520"/>
+            <a:ext cx="406787" cy="310896"/>
           </a:xfrm>
           <a:prstGeom prst="rect">
             <a:avLst/>
@@ -5478,7 +5478,7 @@
         </p:blipFill>
         <p:spPr>
           <a:xfrm>
-            <a:off x="7032752" y="4640580"/>
+            <a:off x="7048596" y="4640580"/>
             <a:ext cx="155448" cy="155448"/>
           </a:xfrm>
           <a:prstGeom prst="rect">
@@ -5494,8 +5494,8 @@
         </p:nvSpPr>
         <p:spPr>
           <a:xfrm>
-            <a:off x="7252208" y="4562856"/>
-            <a:ext cx="391160" cy="310896"/>
+            <a:off x="7268052" y="4562856"/>
+            <a:ext cx="359472" cy="310896"/>
           </a:xfrm>
           <a:prstGeom prst="rect">
             <a:avLst/>
@@ -5573,7 +5573,7 @@
         </p:blipFill>
         <p:spPr>
           <a:xfrm>
-            <a:off x="6969252" y="5042916"/>
+            <a:off x="6967268" y="5042916"/>
             <a:ext cx="155448" cy="155448"/>
           </a:xfrm>
           <a:prstGeom prst="rect">
@@ -5589,8 +5589,8 @@
         </p:nvSpPr>
         <p:spPr>
           <a:xfrm>
-            <a:off x="7188708" y="4965192"/>
-            <a:ext cx="518160" cy="310896"/>
+            <a:off x="7186724" y="4965192"/>
+            <a:ext cx="522129" cy="310896"/>
           </a:xfrm>
           <a:prstGeom prst="rect">
             <a:avLst/>
@@ -5668,7 +5668,7 @@
         </p:blipFill>
         <p:spPr>
           <a:xfrm>
-            <a:off x="7064502" y="5445252"/>
+            <a:off x="7061960" y="5445252"/>
             <a:ext cx="155448" cy="155448"/>
           </a:xfrm>
           <a:prstGeom prst="rect">
@@ -5684,8 +5684,8 @@
         </p:nvSpPr>
         <p:spPr>
           <a:xfrm>
-            <a:off x="7283958" y="5367528"/>
-            <a:ext cx="327660" cy="310896"/>
+            <a:off x="7281416" y="5367528"/>
+            <a:ext cx="332745" cy="310896"/>
           </a:xfrm>
           <a:prstGeom prst="rect">
             <a:avLst/>
@@ -5763,7 +5763,7 @@
         </p:blipFill>
         <p:spPr>
           <a:xfrm>
-            <a:off x="6905752" y="5847588"/>
+            <a:off x="6940137" y="5847588"/>
             <a:ext cx="155448" cy="155448"/>
           </a:xfrm>
           <a:prstGeom prst="rect">
@@ -5779,8 +5779,8 @@
         </p:nvSpPr>
         <p:spPr>
           <a:xfrm>
-            <a:off x="7125208" y="5769864"/>
-            <a:ext cx="645160" cy="310896"/>
+            <a:off x="7159593" y="5769864"/>
+            <a:ext cx="576389" cy="310896"/>
           </a:xfrm>
           <a:prstGeom prst="rect">
             <a:avLst/>

</xml_diff>